<commit_message>
Added API routes for prediction and recommendation
</commit_message>
<xml_diff>
--- a/presentation/Tushar_Nalawade_Capstone_Project.pptx
+++ b/presentation/Tushar_Nalawade_Capstone_Project.pptx
@@ -5010,7 +5010,6 @@
             </a:pPr>
             <a:r>
               <a:rPr lang="en-US" sz="3600" b="1" dirty="0">
-                <a:ln/>
                 <a:solidFill>
                   <a:schemeClr val="tx1"/>
                 </a:solidFill>
@@ -5029,7 +5028,6 @@
               <a:t>Customer Segmentation</a:t>
             </a:r>
             <a:endParaRPr lang="en-US" sz="3600" dirty="0">
-              <a:ln/>
               <a:solidFill>
                 <a:schemeClr val="tx1"/>
               </a:solidFill>
@@ -5053,7 +5051,6 @@
             </a:pPr>
             <a:r>
               <a:rPr lang="en-US" sz="3600" b="1" dirty="0">
-                <a:ln/>
                 <a:solidFill>
                   <a:schemeClr val="tx1"/>
                 </a:solidFill>
@@ -5072,7 +5069,6 @@
               <a:t>&amp; Predictive Modelling</a:t>
             </a:r>
             <a:endParaRPr lang="en-US" sz="3600" b="1" dirty="0">
-              <a:ln/>
               <a:solidFill>
                 <a:schemeClr val="tx1"/>
               </a:solidFill>
@@ -12616,32 +12612,6 @@
           </a:p>
         </p:txBody>
       </p:sp>
-      <p:pic>
-        <p:nvPicPr>
-          <p:cNvPr id="3" name="Content Placeholder 2" descr="output"/>
-          <p:cNvPicPr>
-            <a:picLocks noChangeAspect="1"/>
-          </p:cNvPicPr>
-          <p:nvPr>
-            <p:ph idx="1"/>
-          </p:nvPr>
-        </p:nvPicPr>
-        <p:blipFill>
-          <a:blip r:embed="rId1"/>
-          <a:stretch>
-            <a:fillRect/>
-          </a:stretch>
-        </p:blipFill>
-        <p:spPr>
-          <a:xfrm>
-            <a:off x="6818630" y="1348740"/>
-            <a:ext cx="4846320" cy="4160520"/>
-          </a:xfrm>
-          <a:prstGeom prst="rect">
-            <a:avLst/>
-          </a:prstGeom>
-        </p:spPr>
-      </p:pic>
       <p:sp>
         <p:nvSpPr>
           <p:cNvPr id="2" name="Text Box 1"/>
@@ -13306,6 +13276,32 @@
           </a:p>
         </p:txBody>
       </p:sp>
+      <p:pic>
+        <p:nvPicPr>
+          <p:cNvPr id="7" name="Content Placeholder 6"/>
+          <p:cNvPicPr>
+            <a:picLocks noChangeAspect="1"/>
+          </p:cNvPicPr>
+          <p:nvPr>
+            <p:ph idx="1"/>
+          </p:nvPr>
+        </p:nvPicPr>
+        <p:blipFill>
+          <a:blip r:embed="rId1"/>
+          <a:stretch>
+            <a:fillRect/>
+          </a:stretch>
+        </p:blipFill>
+        <p:spPr>
+          <a:xfrm>
+            <a:off x="6588760" y="1216660"/>
+            <a:ext cx="5048250" cy="4333875"/>
+          </a:xfrm>
+          <a:prstGeom prst="rect">
+            <a:avLst/>
+          </a:prstGeom>
+        </p:spPr>
+      </p:pic>
     </p:spTree>
   </p:cSld>
   <p:clrMapOvr>
@@ -13998,7 +13994,7 @@
                   <a:ea typeface="SimSun" panose="02010600030101010101" pitchFamily="2" charset="-122"/>
                   <a:cs typeface="Georgia Pro Cond Light" panose="02040306050405020303" charset="0"/>
                 </a:rPr>
-                <a:t>Segment label + Risk tier (High/Low) with probabilities</a:t>
+                <a:t>Segment label + Risk tier (High/Mid/Low) with probabilities</a:t>
               </a:r>
               <a:endParaRPr lang="en-US" sz="1600" dirty="0">
                 <a:solidFill>
@@ -15263,7 +15259,7 @@
                 <a:latin typeface="Georgia Pro Cond" panose="02040506050405020303" charset="0"/>
                 <a:cs typeface="Georgia Pro Cond" panose="02040506050405020303" charset="0"/>
               </a:rPr>
-              <a:t>94%</a:t>
+              <a:t>89%</a:t>
             </a:r>
             <a:endParaRPr lang="en-US" altLang="en-GB">
               <a:effectLst>
@@ -15333,7 +15329,7 @@
                 <a:latin typeface="Georgia Pro Cond" panose="02040506050405020303" charset="0"/>
                 <a:cs typeface="Georgia Pro Cond" panose="02040506050405020303" charset="0"/>
               </a:rPr>
-              <a:t>84%</a:t>
+              <a:t>77%</a:t>
             </a:r>
             <a:endParaRPr lang="en-US" altLang="en-GB">
               <a:effectLst>
@@ -15403,7 +15399,7 @@
                 <a:latin typeface="Georgia Pro Cond" panose="02040506050405020303" charset="0"/>
                 <a:cs typeface="Georgia Pro Cond" panose="02040506050405020303" charset="0"/>
               </a:rPr>
-              <a:t>90%</a:t>
+              <a:t>84%</a:t>
             </a:r>
             <a:endParaRPr lang="en-US" altLang="en-GB">
               <a:effectLst>
@@ -15421,7 +15417,7 @@
       </p:sp>
       <p:pic>
         <p:nvPicPr>
-          <p:cNvPr id="16" name="Picture 15"/>
+          <p:cNvPr id="2" name="Picture 1"/>
           <p:cNvPicPr>
             <a:picLocks noChangeAspect="1"/>
           </p:cNvPicPr>
@@ -15435,8 +15431,8 @@
         </p:blipFill>
         <p:spPr>
           <a:xfrm>
-            <a:off x="8328025" y="2119630"/>
-            <a:ext cx="3568700" cy="3143885"/>
+            <a:off x="8298815" y="1972945"/>
+            <a:ext cx="3604895" cy="3187065"/>
           </a:xfrm>
           <a:prstGeom prst="rect">
             <a:avLst/>
@@ -15445,7 +15441,7 @@
       </p:pic>
       <p:pic>
         <p:nvPicPr>
-          <p:cNvPr id="17" name="Picture 16"/>
+          <p:cNvPr id="3" name="Picture 2"/>
           <p:cNvPicPr/>
           <p:nvPr/>
         </p:nvPicPr>
@@ -15457,17 +15453,12 @@
         </p:blipFill>
         <p:spPr>
           <a:xfrm>
-            <a:off x="1584325" y="3124200"/>
-            <a:ext cx="4633595" cy="2885440"/>
+            <a:off x="1868805" y="3176270"/>
+            <a:ext cx="4241800" cy="2790190"/>
           </a:xfrm>
           <a:prstGeom prst="rect">
             <a:avLst/>
           </a:prstGeom>
-          <a:ln>
-            <a:solidFill>
-              <a:schemeClr val="accent1"/>
-            </a:solidFill>
-          </a:ln>
         </p:spPr>
       </p:pic>
     </p:spTree>
@@ -15583,7 +15574,7 @@
                   <a:ea typeface="SimSun" panose="02010600030101010101" pitchFamily="2" charset="-122"/>
                   <a:cs typeface="Georgia Pro Cond Light" panose="02040306050405020303" charset="0"/>
                 </a:rPr>
-                <a:t> identified via KMeans + GMM with 95% classification accuracy</a:t>
+                <a:t> identified via KMeans + GMM with 89% classification accuracy</a:t>
               </a:r>
               <a:endParaRPr lang="en-US" sz="1600" dirty="0">
                 <a:latin typeface="Georgia Pro Cond Light" panose="02040306050405020303" charset="0"/>
@@ -15633,7 +15624,7 @@
                   <a:ea typeface="SimSun" panose="02010600030101010101" pitchFamily="2" charset="-122"/>
                   <a:cs typeface="Georgia Pro Cond Light" panose="02040306050405020303" charset="0"/>
                 </a:rPr>
-                <a:t>VIP customers (32%)</a:t>
+                <a:t>VIP customers (2%)</a:t>
               </a:r>
               <a:r>
                 <a:rPr lang="en-US" sz="1600" dirty="0">
@@ -15644,9 +15635,20 @@
                   <a:ea typeface="SimSun" panose="02010600030101010101" pitchFamily="2" charset="-122"/>
                   <a:cs typeface="Georgia Pro Cond Light" panose="02040306050405020303" charset="0"/>
                 </a:rPr>
-                <a:t> drive 67% of total revenue — top retention priority</a:t>
+                <a:t> drive 88% of total revenue &gt;&gt; </a:t>
               </a:r>
-              <a:endParaRPr lang="en-US" sz="1600" dirty="0">
+              <a:r>
+                <a:rPr lang="en-US" sz="1600" u="sng" dirty="0">
+                  <a:solidFill>
+                    <a:srgbClr val="334155"/>
+                  </a:solidFill>
+                  <a:latin typeface="Georgia Pro Cond Light" panose="02040306050405020303" charset="0"/>
+                  <a:ea typeface="SimSun" panose="02010600030101010101" pitchFamily="2" charset="-122"/>
+                  <a:cs typeface="Georgia Pro Cond Light" panose="02040306050405020303" charset="0"/>
+                </a:rPr>
+                <a:t>top retention priority</a:t>
+              </a:r>
+              <a:endParaRPr lang="en-US" sz="1600" u="sng" dirty="0">
                 <a:latin typeface="Georgia Pro Cond Light" panose="02040306050405020303" charset="0"/>
                 <a:cs typeface="Georgia Pro Cond Light" panose="02040306050405020303" charset="0"/>
               </a:endParaRPr>
@@ -15694,7 +15696,7 @@
                   <a:ea typeface="SimSun" panose="02010600030101010101" pitchFamily="2" charset="-122"/>
                   <a:cs typeface="Georgia Pro Cond Light" panose="02040306050405020303" charset="0"/>
                 </a:rPr>
-                <a:t>20% at-risk customers</a:t>
+                <a:t>12% at-risk customers</a:t>
               </a:r>
               <a:r>
                 <a:rPr lang="en-US" sz="1600" dirty="0">
@@ -15705,10 +15707,25 @@
                   <a:ea typeface="SimSun" panose="02010600030101010101" pitchFamily="2" charset="-122"/>
                   <a:cs typeface="Georgia Pro Cond Light" panose="02040306050405020303" charset="0"/>
                 </a:rPr>
-                <a:t> with early churn signals — winback window: 30 days</a:t>
+                <a:t> with early churn signals &gt;&gt; </a:t>
               </a:r>
-              <a:endParaRPr lang="en-US" sz="1600" dirty="0">
+              <a:r>
+                <a:rPr lang="en-US" sz="1600" u="sng" dirty="0">
+                  <a:solidFill>
+                    <a:srgbClr val="334155"/>
+                  </a:solidFill>
+                  <a:latin typeface="Georgia Pro Cond Light" panose="02040306050405020303" charset="0"/>
+                  <a:ea typeface="SimSun" panose="02010600030101010101" pitchFamily="2" charset="-122"/>
+                  <a:cs typeface="Georgia Pro Cond Light" panose="02040306050405020303" charset="0"/>
+                </a:rPr>
+                <a:t>winback window: 30 days</a:t>
+              </a:r>
+              <a:endParaRPr lang="en-US" sz="1600" u="sng" dirty="0">
+                <a:solidFill>
+                  <a:srgbClr val="334155"/>
+                </a:solidFill>
                 <a:latin typeface="Georgia Pro Cond Light" panose="02040306050405020303" charset="0"/>
+                <a:ea typeface="SimSun" panose="02010600030101010101" pitchFamily="2" charset="-122"/>
                 <a:cs typeface="Georgia Pro Cond Light" panose="02040306050405020303" charset="0"/>
               </a:endParaRPr>
             </a:p>

</xml_diff>